<commit_message>
Restrict presentation to content from The LLM Context Tax article only
Remove content from other sources (arXiv papers, ACL research, etc).
Extract solely from Nicolas Bustamante's article at nicolasbustamante.com.

Co-authored-by: ms4674 <ms4674@users.noreply.github.com>
</commit_message>
<xml_diff>
--- a/LLM_Information_Efficiency_Presentation.pptx
+++ b/LLM_Information_Efficiency_Presentation.pptx
@@ -14,7 +14,6 @@
     <p:sldId id="262" r:id="rId13"/>
     <p:sldId id="263" r:id="rId14"/>
     <p:sldId id="264" r:id="rId15"/>
-    <p:sldId id="265" r:id="rId16"/>
   </p:sldIdLst>
   <p:sldSz cx="9144000" cy="6858000" type="screen4x3"/>
   <p:notesSz cx="6858000" cy="9144000"/>
@@ -3113,7 +3112,7 @@
           <a:lstStyle/>
           <a:p>
             <a:r>
-              <a:t>LLMs: A More Efficient Way of Gathering Information</a:t>
+              <a:t>The LLM Context Tax: Best Tips for Tax Avoidance</a:t>
             </a:r>
           </a:p>
         </p:txBody>
@@ -3139,137 +3138,7 @@
           </a:p>
           <a:p>
             <a:r>
-              <a:t>Based on research by Nicolas Bustamante &amp; recent LLM efficiency studies</a:t>
-            </a:r>
-          </a:p>
-        </p:txBody>
-      </p:sp>
-    </p:spTree>
-  </p:cSld>
-  <p:clrMapOvr>
-    <a:masterClrMapping/>
-  </p:clrMapOvr>
-</p:sld>
-</file>
-
-<file path=ppt/slides/slide10.xml><?xml version="1.0" encoding="utf-8"?>
-<p:sld xmlns:a="http://schemas.openxmlformats.org/drawingml/2006/main" xmlns:p="http://schemas.openxmlformats.org/presentationml/2006/main" xmlns:r="http://schemas.openxmlformats.org/officeDocument/2006/relationships">
-  <p:cSld>
-    <p:spTree>
-      <p:nvGrpSpPr>
-        <p:cNvPr id="1" name=""/>
-        <p:cNvGrpSpPr/>
-        <p:nvPr/>
-      </p:nvGrpSpPr>
-      <p:grpSpPr/>
-      <p:sp>
-        <p:nvSpPr>
-          <p:cNvPr id="2" name="Title 1"/>
-          <p:cNvSpPr>
-            <a:spLocks noGrp="1"/>
-          </p:cNvSpPr>
-          <p:nvPr>
-            <p:ph type="title"/>
-          </p:nvPr>
-        </p:nvSpPr>
-        <p:spPr/>
-        <p:txBody>
-          <a:bodyPr/>
-          <a:lstStyle/>
-          <a:p>
-            <a:r>
-              <a:t>Sources</a:t>
-            </a:r>
-          </a:p>
-        </p:txBody>
-      </p:sp>
-      <p:sp>
-        <p:nvSpPr>
-          <p:cNvPr id="3" name="Content Placeholder 2"/>
-          <p:cNvSpPr>
-            <a:spLocks noGrp="1"/>
-          </p:cNvSpPr>
-          <p:nvPr>
-            <p:ph idx="1"/>
-          </p:nvPr>
-        </p:nvSpPr>
-        <p:spPr/>
-        <p:txBody>
-          <a:bodyPr/>
-          <a:lstStyle/>
-          <a:p>
-            <a:pPr>
-              <a:spcAft>
-                <a:spcPts val="1200"/>
-              </a:spcAft>
-              <a:defRPr sz="1800">
-                <a:solidFill>
-                  <a:srgbClr val="3D3D5C"/>
-                </a:solidFill>
-              </a:defRPr>
-            </a:pPr>
-            <a:r>
-              <a:t>Nicolas Bustamante — The LLM Context Tax: Best Tips for Tax Avoidance (nicolasbustamante.com)</a:t>
-            </a:r>
-          </a:p>
-          <a:p>
-            <a:pPr>
-              <a:spcAft>
-                <a:spcPts val="1200"/>
-              </a:spcAft>
-              <a:defRPr sz="1800">
-                <a:solidFill>
-                  <a:srgbClr val="3D3D5C"/>
-                </a:solidFill>
-              </a:defRPr>
-            </a:pPr>
-            <a:r>
-              <a:t>How Well do LLMs Compress Their Own Chain-of-Thought? — Token Complexity Approach (arXiv 2503.01141)</a:t>
-            </a:r>
-          </a:p>
-          <a:p>
-            <a:pPr>
-              <a:spcAft>
-                <a:spcPts val="1200"/>
-              </a:spcAft>
-              <a:defRPr sz="1800">
-                <a:solidFill>
-                  <a:srgbClr val="3D3D5C"/>
-                </a:solidFill>
-              </a:defRPr>
-            </a:pPr>
-            <a:r>
-              <a:t>OckBench: Measuring the Efficiency of LLM Reasoning (arXiv 2511.05722)</a:t>
-            </a:r>
-          </a:p>
-          <a:p>
-            <a:pPr>
-              <a:spcAft>
-                <a:spcPts val="1200"/>
-              </a:spcAft>
-              <a:defRPr sz="1800">
-                <a:solidFill>
-                  <a:srgbClr val="3D3D5C"/>
-                </a:solidFill>
-              </a:defRPr>
-            </a:pPr>
-            <a:r>
-              <a:t>How Far are LLMs from Real Search? — Efficiency, Completeness Study (arXiv 2502.18387)</a:t>
-            </a:r>
-          </a:p>
-          <a:p>
-            <a:pPr>
-              <a:spcAft>
-                <a:spcPts val="1200"/>
-              </a:spcAft>
-              <a:defRPr sz="1800">
-                <a:solidFill>
-                  <a:srgbClr val="3D3D5C"/>
-                </a:solidFill>
-              </a:defRPr>
-            </a:pPr>
-            <a:r>
-              <a:t>FreshLLMs: Search Engine Augmentation for LLMs (ACL 2024)</a:t>
+              <a:t>Nicolas Bustamante — nicolasbustamante.com</a:t>
             </a:r>
           </a:p>
         </p:txBody>
@@ -3308,7 +3177,7 @@
           <a:lstStyle/>
           <a:p>
             <a:r>
-              <a:t>The Information Efficiency Challenge</a:t>
+              <a:t>What Is the Context Tax?</a:t>
             </a:r>
           </a:p>
         </p:txBody>
@@ -3339,7 +3208,7 @@
               </a:defRPr>
             </a:pPr>
             <a:r>
-              <a:t>Traditional search: Multiple queries, scattered results, manual synthesis</a:t>
+              <a:t>The cumulative costs of filling an LLM's context window with unnecessary tokens</a:t>
             </a:r>
           </a:p>
           <a:p>
@@ -3354,7 +3223,7 @@
               </a:defRPr>
             </a:pPr>
             <a:r>
-              <a:t>Every token sent to an LLM costs money, adds latency, and can degrade performance</a:t>
+              <a:t>Every token sent to an LLM incurs three penalties: higher costs, slower responses, degraded performance</a:t>
             </a:r>
           </a:p>
           <a:p>
@@ -3369,7 +3238,7 @@
               </a:defRPr>
             </a:pPr>
             <a:r>
-              <a:t>Context rot: Agents become confused by accumulated noise in long conversations</a:t>
+              <a:t>Context rot: Agents become confused by accumulated noise</a:t>
             </a:r>
           </a:p>
           <a:p>
@@ -3384,7 +3253,7 @@
               </a:defRPr>
             </a:pPr>
             <a:r>
-              <a:t>The goal: Get more value from fewer tokens—smarter, not harder</a:t>
+              <a:t>Most models show sharp performance degradation past 32K tokens</a:t>
             </a:r>
           </a:p>
         </p:txBody>
@@ -3538,7 +3407,7 @@
           <a:lstStyle/>
           <a:p>
             <a:r>
-              <a:t>Top Strategies for Information Efficiency</a:t>
+              <a:t>Most Critical Optimizations</a:t>
             </a:r>
           </a:p>
         </p:txBody>
@@ -3660,8 +3529,8 @@
         </p:nvSpPr>
         <p:spPr>
           <a:xfrm>
-            <a:off x="457200" y="274320"/>
-            <a:ext cx="8229600" cy="731520"/>
+            <a:off x="457200" y="1828800"/>
+            <a:ext cx="8229600" cy="1828800"/>
           </a:xfrm>
           <a:prstGeom prst="rect">
             <a:avLst/>
@@ -3669,20 +3538,20 @@
           <a:noFill/>
         </p:spPr>
         <p:txBody>
-          <a:bodyPr wrap="none">
+          <a:bodyPr wrap="square">
             <a:spAutoFit/>
           </a:bodyPr>
           <a:lstStyle/>
           <a:p>
-            <a:pPr>
-              <a:defRPr sz="2800" b="1">
-                <a:solidFill>
-                  <a:srgbClr val="1A1A2E"/>
+            <a:pPr algn="ctr">
+              <a:defRPr sz="2400" i="1">
+                <a:solidFill>
+                  <a:srgbClr val="166F97"/>
                 </a:solidFill>
               </a:defRPr>
             </a:pPr>
             <a:r>
-              <a:t>LLMs vs. Traditional Search: Efficiency Gains</a:t>
+              <a:t>"The most important optimization for production agents: maintaining stable prefixes for KV cache hits—offering up to 10x cost reduction"</a:t>
             </a:r>
           </a:p>
         </p:txBody>
@@ -3695,8 +3564,8 @@
         </p:nvSpPr>
         <p:spPr>
           <a:xfrm>
-            <a:off x="457200" y="1188720"/>
-            <a:ext cx="4114800" cy="4572000"/>
+            <a:off x="457200" y="3840480"/>
+            <a:ext cx="8229600" cy="457200"/>
           </a:xfrm>
           <a:prstGeom prst="rect">
             <a:avLst/>
@@ -3704,151 +3573,20 @@
           <a:noFill/>
         </p:spPr>
         <p:txBody>
-          <a:bodyPr wrap="square">
+          <a:bodyPr wrap="none">
             <a:spAutoFit/>
           </a:bodyPr>
           <a:lstStyle/>
           <a:p>
-            <a:pPr>
-              <a:spcAft>
-                <a:spcPts val="800"/>
-              </a:spcAft>
-              <a:defRPr sz="1600">
+            <a:pPr algn="ctr">
+              <a:defRPr sz="1400">
                 <a:solidFill>
                   <a:srgbClr val="3D3D5C"/>
                 </a:solidFill>
               </a:defRPr>
             </a:pPr>
             <a:r>
-              <a:t>• Reduce search space by up to 99.1% with guided strategies</a:t>
-            </a:r>
-          </a:p>
-          <a:p>
-            <a:pPr>
-              <a:spcAft>
-                <a:spcPts val="800"/>
-              </a:spcAft>
-              <a:defRPr sz="1600">
-                <a:solidFill>
-                  <a:srgbClr val="3D3D5C"/>
-                </a:solidFill>
-              </a:defRPr>
-            </a:pPr>
-            <a:r>
-              <a:t>• Synthesize information across sources in one interaction</a:t>
-            </a:r>
-          </a:p>
-          <a:p>
-            <a:pPr>
-              <a:spcAft>
-                <a:spcPts val="800"/>
-              </a:spcAft>
-              <a:defRPr sz="1600">
-                <a:solidFill>
-                  <a:srgbClr val="3D3D5C"/>
-                </a:solidFill>
-              </a:defRPr>
-            </a:pPr>
-            <a:r>
-              <a:t>• Speed up explorations and decisions on broad topics</a:t>
-            </a:r>
-          </a:p>
-          <a:p>
-            <a:pPr>
-              <a:spcAft>
-                <a:spcPts val="800"/>
-              </a:spcAft>
-              <a:defRPr sz="1600">
-                <a:solidFill>
-                  <a:srgbClr val="3D3D5C"/>
-                </a:solidFill>
-              </a:defRPr>
-            </a:pPr>
-            <a:r>
-              <a:t>• Combine reasoning with retrieval for comprehensive answers</a:t>
-            </a:r>
-          </a:p>
-        </p:txBody>
-      </p:sp>
-      <p:sp>
-        <p:nvSpPr>
-          <p:cNvPr id="4" name="TextBox 3"/>
-          <p:cNvSpPr txBox="1"/>
-          <p:nvPr/>
-        </p:nvSpPr>
-        <p:spPr>
-          <a:xfrm>
-            <a:off x="4572000" y="1188720"/>
-            <a:ext cx="4114800" cy="4572000"/>
-          </a:xfrm>
-          <a:prstGeom prst="rect">
-            <a:avLst/>
-          </a:prstGeom>
-          <a:noFill/>
-        </p:spPr>
-        <p:txBody>
-          <a:bodyPr wrap="square">
-            <a:spAutoFit/>
-          </a:bodyPr>
-          <a:lstStyle/>
-          <a:p>
-            <a:pPr>
-              <a:spcAft>
-                <a:spcPts val="800"/>
-              </a:spcAft>
-              <a:defRPr sz="1600">
-                <a:solidFill>
-                  <a:srgbClr val="3D3D5C"/>
-                </a:solidFill>
-              </a:defRPr>
-            </a:pPr>
-            <a:r>
-              <a:t>• Traditional search: Many queries, manual filtering</a:t>
-            </a:r>
-          </a:p>
-          <a:p>
-            <a:pPr>
-              <a:spcAft>
-                <a:spcPts val="800"/>
-              </a:spcAft>
-              <a:defRPr sz="1600">
-                <a:solidFill>
-                  <a:srgbClr val="3D3D5C"/>
-                </a:solidFill>
-              </a:defRPr>
-            </a:pPr>
-            <a:r>
-              <a:t>• LLMs: Single conversational query, integrated synthesis</a:t>
-            </a:r>
-          </a:p>
-          <a:p>
-            <a:pPr>
-              <a:spcAft>
-                <a:spcPts val="800"/>
-              </a:spcAft>
-              <a:defRPr sz="1600">
-                <a:solidFill>
-                  <a:srgbClr val="3D3D5C"/>
-                </a:solidFill>
-              </a:defRPr>
-            </a:pPr>
-            <a:r>
-              <a:t>• Best approach: LLMs augmented with search (FreshPrompt method)</a:t>
-            </a:r>
-          </a:p>
-          <a:p>
-            <a:pPr>
-              <a:spcAft>
-                <a:spcPts val="800"/>
-              </a:spcAft>
-              <a:defRPr sz="1600">
-                <a:solidFill>
-                  <a:srgbClr val="3D3D5C"/>
-                </a:solidFill>
-              </a:defRPr>
-            </a:pPr>
-            <a:r>
-              <a:t>• Dense retrievers outperform BM25 by 24.8% on scientific literature</a:t>
+              <a:t>— Nicolas Bustamante, The LLM Context Tax</a:t>
             </a:r>
           </a:p>
         </p:txBody>
@@ -3873,70 +3611,112 @@
       <p:grpSpPr/>
       <p:sp>
         <p:nvSpPr>
-          <p:cNvPr id="2" name="TextBox 1"/>
-          <p:cNvSpPr txBox="1"/>
-          <p:nvPr/>
-        </p:nvSpPr>
-        <p:spPr>
-          <a:xfrm>
-            <a:off x="457200" y="1828800"/>
-            <a:ext cx="8229600" cy="1828800"/>
-          </a:xfrm>
-          <a:prstGeom prst="rect">
-            <a:avLst/>
-          </a:prstGeom>
-          <a:noFill/>
-        </p:spPr>
-        <p:txBody>
-          <a:bodyPr wrap="square">
-            <a:spAutoFit/>
-          </a:bodyPr>
-          <a:lstStyle/>
-          <a:p>
-            <a:pPr algn="ctr">
-              <a:defRPr sz="2400" i="1">
-                <a:solidFill>
-                  <a:srgbClr val="166F97"/>
+          <p:cNvPr id="2" name="Title 1"/>
+          <p:cNvSpPr>
+            <a:spLocks noGrp="1"/>
+          </p:cNvSpPr>
+          <p:nvPr>
+            <p:ph type="title"/>
+          </p:nvPr>
+        </p:nvSpPr>
+        <p:spPr/>
+        <p:txBody>
+          <a:bodyPr/>
+          <a:lstStyle/>
+          <a:p>
+            <a:r>
+              <a:t>Output Token Budgeting: The Hidden Cost</a:t>
+            </a:r>
+          </a:p>
+        </p:txBody>
+      </p:sp>
+      <p:sp>
+        <p:nvSpPr>
+          <p:cNvPr id="3" name="Content Placeholder 2"/>
+          <p:cNvSpPr>
+            <a:spLocks noGrp="1"/>
+          </p:cNvSpPr>
+          <p:nvPr>
+            <p:ph idx="1"/>
+          </p:nvPr>
+        </p:nvSpPr>
+        <p:spPr/>
+        <p:txBody>
+          <a:bodyPr/>
+          <a:lstStyle/>
+          <a:p>
+            <a:pPr>
+              <a:spcAft>
+                <a:spcPts val="1200"/>
+              </a:spcAft>
+              <a:defRPr sz="1800">
+                <a:solidFill>
+                  <a:srgbClr val="3D3D5C"/>
                 </a:solidFill>
               </a:defRPr>
             </a:pPr>
             <a:r>
-              <a:t>"The most important optimization for production agents: maintaining stable prefixes for KV cache hits—offering up to 10x cost reduction"</a:t>
-            </a:r>
-          </a:p>
-        </p:txBody>
-      </p:sp>
-      <p:sp>
-        <p:nvSpPr>
-          <p:cNvPr id="3" name="TextBox 2"/>
-          <p:cNvSpPr txBox="1"/>
-          <p:nvPr/>
-        </p:nvSpPr>
-        <p:spPr>
-          <a:xfrm>
-            <a:off x="457200" y="3840480"/>
-            <a:ext cx="8229600" cy="457200"/>
-          </a:xfrm>
-          <a:prstGeom prst="rect">
-            <a:avLst/>
-          </a:prstGeom>
-          <a:noFill/>
-        </p:spPr>
-        <p:txBody>
-          <a:bodyPr wrap="none">
-            <a:spAutoFit/>
-          </a:bodyPr>
-          <a:lstStyle/>
-          <a:p>
-            <a:pPr algn="ctr">
-              <a:defRPr sz="1400">
+              <a:t>Output tokens cost 5x more than uncached input tokens</a:t>
+            </a:r>
+          </a:p>
+          <a:p>
+            <a:pPr>
+              <a:spcAft>
+                <a:spcPts val="1200"/>
+              </a:spcAft>
+              <a:defRPr sz="1800">
                 <a:solidFill>
                   <a:srgbClr val="3D3D5C"/>
                 </a:solidFill>
               </a:defRPr>
             </a:pPr>
             <a:r>
-              <a:t>— Nicolas Bustamante, The LLM Context Tax</a:t>
+              <a:t>The most expensive tokens are those you generate</a:t>
+            </a:r>
+          </a:p>
+          <a:p>
+            <a:pPr>
+              <a:spcAft>
+                <a:spcPts val="1200"/>
+              </a:spcAft>
+              <a:defRPr sz="1800">
+                <a:solidFill>
+                  <a:srgbClr val="3D3D5C"/>
+                </a:solidFill>
+              </a:defRPr>
+            </a:pPr>
+            <a:r>
+              <a:t>Budget outputs carefully — request concise responses when possible</a:t>
+            </a:r>
+          </a:p>
+          <a:p>
+            <a:pPr>
+              <a:spcAft>
+                <a:spcPts val="1200"/>
+              </a:spcAft>
+              <a:defRPr sz="1800">
+                <a:solidFill>
+                  <a:srgbClr val="3D3D5C"/>
+                </a:solidFill>
+              </a:defRPr>
+            </a:pPr>
+            <a:r>
+              <a:t>Delegate token-heavy operations to cheaper subagents</a:t>
+            </a:r>
+          </a:p>
+          <a:p>
+            <a:pPr>
+              <a:spcAft>
+                <a:spcPts val="1200"/>
+              </a:spcAft>
+              <a:defRPr sz="1800">
+                <a:solidFill>
+                  <a:srgbClr val="3D3D5C"/>
+                </a:solidFill>
+              </a:defRPr>
+            </a:pPr>
+            <a:r>
+              <a:t>Reusable templates — stop regenerating the same code repeatedly</a:t>
             </a:r>
           </a:p>
         </p:txBody>
@@ -3975,7 +3755,7 @@
           <a:lstStyle/>
           <a:p>
             <a:r>
-              <a:t>Output Token Budgeting: The Hidden Cost</a:t>
+              <a:t>Additional Optimization Tactics</a:t>
             </a:r>
           </a:p>
         </p:txBody>
@@ -4006,7 +3786,7 @@
               </a:defRPr>
             </a:pPr>
             <a:r>
-              <a:t>Output tokens cost 5x more than uncached input tokens</a:t>
+              <a:t>Clean data before it enters context</a:t>
             </a:r>
           </a:p>
           <a:p>
@@ -4021,7 +3801,7 @@
               </a:defRPr>
             </a:pPr>
             <a:r>
-              <a:t>The most expensive tokens are those you generate</a:t>
+              <a:t>Use strategic information placement to avoid the lost-in-the-middle problem</a:t>
             </a:r>
           </a:p>
           <a:p>
@@ -4036,7 +3816,7 @@
               </a:defRPr>
             </a:pPr>
             <a:r>
-              <a:t>Budget outputs carefully — request concise responses when possible</a:t>
+              <a:t>Avoid the 200K token pricing cliff</a:t>
             </a:r>
           </a:p>
           <a:p>
@@ -4051,7 +3831,7 @@
               </a:defRPr>
             </a:pPr>
             <a:r>
-              <a:t>Delegate token-heavy operations to cheaper subagents</a:t>
+              <a:t>Append-only context — mutating context destroys cache efficiency</a:t>
             </a:r>
           </a:p>
           <a:p>
@@ -4066,7 +3846,7 @@
               </a:defRPr>
             </a:pPr>
             <a:r>
-              <a:t>Reusable templates — stop regenerating the same code repeatedly</a:t>
+              <a:t>Never include timestamps precise to the second in prompts; move all dynamic content to the end</a:t>
             </a:r>
           </a:p>
         </p:txBody>
@@ -4105,7 +3885,7 @@
           <a:lstStyle/>
           <a:p>
             <a:r>
-              <a:t>Best Practices for Efficient Information Gathering</a:t>
+              <a:t>Key Takeaways</a:t>
             </a:r>
           </a:p>
         </p:txBody>
@@ -4136,7 +3916,7 @@
               </a:defRPr>
             </a:pPr>
             <a:r>
-              <a:t>Use LLMs for synthesis; augment with search for specific/niche knowledge</a:t>
+              <a:t>With Claude Opus 4.6, cached input tokens cost 90% less than uncached (10x cost difference)</a:t>
             </a:r>
           </a:p>
           <a:p>
@@ -4151,7 +3931,7 @@
               </a:defRPr>
             </a:pPr>
             <a:r>
-              <a:t>Optimize prompt structure: static content first, dynamic content last</a:t>
+              <a:t>The difference between $0.50 and $5.00 per query often comes down to context management</a:t>
             </a:r>
           </a:p>
           <a:p>
@@ -4166,7 +3946,7 @@
               </a:defRPr>
             </a:pPr>
             <a:r>
-              <a:t>Measure accuracy-efficiency trade-offs—tokens are not free</a:t>
+              <a:t>Stable prefixes for KV cache hits is the single most important optimization for production agents</a:t>
             </a:r>
           </a:p>
           <a:p>
@@ -4181,22 +3961,7 @@
               </a:defRPr>
             </a:pPr>
             <a:r>
-              <a:t>Adaptive compression: shorter responses for easier questions</a:t>
-            </a:r>
-          </a:p>
-          <a:p>
-            <a:pPr>
-              <a:spcAft>
-                <a:spcPts val="1200"/>
-              </a:spcAft>
-              <a:defRPr sz="1800">
-                <a:solidFill>
-                  <a:srgbClr val="3D3D5C"/>
-                </a:solidFill>
-              </a:defRPr>
-            </a:pPr>
-            <a:r>
-              <a:t>Treat efficiency as a first-class evaluation metric</a:t>
+              <a:t>Output tokens cost 5x more than uncached inputs — budget them carefully</a:t>
             </a:r>
           </a:p>
         </p:txBody>
@@ -4235,7 +4000,7 @@
           <a:lstStyle/>
           <a:p>
             <a:r>
-              <a:t>Key Takeaways</a:t>
+              <a:t>Source</a:t>
             </a:r>
           </a:p>
         </p:txBody>
@@ -4266,7 +4031,7 @@
               </a:defRPr>
             </a:pPr>
             <a:r>
-              <a:t>LLMs offer a more efficient information gathering paradigm when optimized</a:t>
+              <a:t>Nicolas Bustamante — The LLM Context Tax: Best Tips for Tax Avoidance</a:t>
             </a:r>
           </a:p>
           <a:p>
@@ -4281,37 +4046,7 @@
               </a:defRPr>
             </a:pPr>
             <a:r>
-              <a:t>Context management is the difference between 10x cost variations</a:t>
-            </a:r>
-          </a:p>
-          <a:p>
-            <a:pPr>
-              <a:spcAft>
-                <a:spcPts val="1200"/>
-              </a:spcAft>
-              <a:defRPr sz="1800">
-                <a:solidFill>
-                  <a:srgbClr val="3D3D5C"/>
-                </a:solidFill>
-              </a:defRPr>
-            </a:pPr>
-            <a:r>
-              <a:t>Strategic design—cache hits, tool precision, parallel calls—drives efficiency</a:t>
-            </a:r>
-          </a:p>
-          <a:p>
-            <a:pPr>
-              <a:spcAft>
-                <a:spcPts val="1200"/>
-              </a:spcAft>
-              <a:defRPr sz="1800">
-                <a:solidFill>
-                  <a:srgbClr val="3D3D5C"/>
-                </a:solidFill>
-              </a:defRPr>
-            </a:pPr>
-            <a:r>
-              <a:t>The future: LLMs + search integration for comprehensive, cost-effective intelligence</a:t>
+              <a:t>https://www.nicolasbustamante.com/p/the-llm-context-tax-best-tips-for</a:t>
             </a:r>
           </a:p>
         </p:txBody>

</xml_diff>